<commit_message>
refactor(pipeline): W-1~W-5 대형 구조 개선 완료 W-1: use-im-data-form.ts 포스처별 서브훅 분리 (use-posture-form-state, use-logistics-form-state) W-2: im-data-bottom-sheet.tsx 인라인 UI 컴포넌트화 (LogisticsSpecSection, VacancySection 추출) W-3: layers.finance / layers.lease_summary 이중 저장 동기화 헬퍼 (lease-data-sync.ts syncLeaseData, getLeaseData) W-5: data-binder.ts 포스처별 인라인 바인딩 및 안전망 로직 분리 (posture-dispatch.ts)
</commit_message>
<xml_diff>
--- a/docs/test/golden-outputs/p6-hotel-r2/hotel_operating_r2_basic.pptx
+++ b/docs/test/golden-outputs/p6-hotel-r2/hotel_operating_r2_basic.pptx
@@ -1692,7 +1692,7 @@
         <p:spPr>
           <a:xfrm>
             <a:off x="502920" y="3090672"/>
-            <a:ext cx="7315200" cy="365760"/>
+            <a:ext cx="7315200" cy="329184"/>
           </a:xfrm>
           <a:prstGeom prst="rect">
             <a:avLst/>
@@ -1730,8 +1730,8 @@
         </p:nvSpPr>
         <p:spPr>
           <a:xfrm>
-            <a:off x="502920" y="3456432"/>
-            <a:ext cx="7315200" cy="292608"/>
+            <a:off x="502920" y="3474720"/>
+            <a:ext cx="7315200" cy="256032"/>
           </a:xfrm>
           <a:prstGeom prst="rect">
             <a:avLst/>
@@ -1769,7 +1769,7 @@
         </p:nvSpPr>
         <p:spPr>
           <a:xfrm>
-            <a:off x="502920" y="3977640"/>
+            <a:off x="502920" y="3895344"/>
             <a:ext cx="1243584" cy="292608"/>
           </a:xfrm>
           <a:prstGeom prst="roundRect">
@@ -1791,7 +1791,7 @@
         </p:nvSpPr>
         <p:spPr>
           <a:xfrm>
-            <a:off x="502920" y="3977640"/>
+            <a:off x="502920" y="3895344"/>
             <a:ext cx="1243584" cy="292608"/>
           </a:xfrm>
           <a:prstGeom prst="rect">
@@ -1830,7 +1830,7 @@
         </p:nvSpPr>
         <p:spPr>
           <a:xfrm>
-            <a:off x="1837944" y="3977640"/>
+            <a:off x="1837944" y="3895344"/>
             <a:ext cx="1005840" cy="292608"/>
           </a:xfrm>
           <a:prstGeom prst="roundRect">
@@ -1852,7 +1852,7 @@
         </p:nvSpPr>
         <p:spPr>
           <a:xfrm>
-            <a:off x="1837944" y="3977640"/>
+            <a:off x="1837944" y="3895344"/>
             <a:ext cx="1005840" cy="292608"/>
           </a:xfrm>
           <a:prstGeom prst="rect">
@@ -1891,7 +1891,7 @@
         </p:nvSpPr>
         <p:spPr>
           <a:xfrm>
-            <a:off x="502920" y="4480560"/>
+            <a:off x="502920" y="4334256"/>
             <a:ext cx="6858000" cy="1051560"/>
           </a:xfrm>
           <a:prstGeom prst="roundRect">
@@ -1918,7 +1918,7 @@
         </p:nvSpPr>
         <p:spPr>
           <a:xfrm>
-            <a:off x="758952" y="4590288"/>
+            <a:off x="758952" y="4443984"/>
             <a:ext cx="6345936" cy="832104"/>
           </a:xfrm>
           <a:prstGeom prst="rect">
@@ -2021,7 +2021,7 @@
                 <a:ea typeface="맑은 고딕" pitchFamily="34" charset="-122"/>
                 <a:cs typeface="맑은 고딕" pitchFamily="34" charset="-120"/>
               </a:rPr>
-              <a:t>2026.09.20  |  담당자  |  CREDEAL</a:t>
+              <a:t>2026.09.22  |  담당자  |  CREDEAL</a:t>
             </a:r>
             <a:endParaRPr lang="en-US" sz="900" dirty="0"/>
           </a:p>
@@ -2060,7 +2060,7 @@
                 <a:ea typeface="맑은 고딕" pitchFamily="34" charset="-122"/>
                 <a:cs typeface="맑은 고딕" pitchFamily="34" charset="-120"/>
               </a:rPr>
-              <a:t>CRE DEAL   |   </a:t>
+              <a:t>CRE DEAL</a:t>
             </a:r>
             <a:endParaRPr lang="en-US" sz="800" dirty="0"/>
           </a:p>
@@ -2364,10 +2364,13 @@
           <a:lstStyle/>
           <a:p>
             <a:pPr indent="0" marL="0">
-              <a:buNone/>
-            </a:pPr>
-            <a:r>
-              <a:rPr lang="en-US" sz="1700" b="1" dirty="0">
+              <a:lnSpc>
+                <a:spcPct val="100000"/>
+              </a:lnSpc>
+              <a:buNone/>
+            </a:pPr>
+            <a:r>
+              <a:rPr lang="en-US" sz="2200" b="1" dirty="0">
                 <a:solidFill>
                   <a:srgbClr val="132A3A"/>
                 </a:solidFill>
@@ -2377,7 +2380,7 @@
               </a:rPr>
               <a:t>300억 원</a:t>
             </a:r>
-            <a:endParaRPr lang="en-US" sz="1700" dirty="0"/>
+            <a:endParaRPr lang="en-US" sz="2200" dirty="0"/>
           </a:p>
         </p:txBody>
       </p:sp>
@@ -2471,10 +2474,13 @@
           <a:lstStyle/>
           <a:p>
             <a:pPr indent="0" marL="0">
-              <a:buNone/>
-            </a:pPr>
-            <a:r>
-              <a:rPr lang="en-US" sz="1700" b="1" dirty="0">
+              <a:lnSpc>
+                <a:spcPct val="100000"/>
+              </a:lnSpc>
+              <a:buNone/>
+            </a:pPr>
+            <a:r>
+              <a:rPr lang="en-US" sz="2200" b="1" dirty="0">
                 <a:solidFill>
                   <a:srgbClr val="132A3A"/>
                 </a:solidFill>
@@ -2484,7 +2490,7 @@
               </a:rPr>
               <a:t>147.1평</a:t>
             </a:r>
-            <a:endParaRPr lang="en-US" sz="1700" dirty="0"/>
+            <a:endParaRPr lang="en-US" sz="2200" dirty="0"/>
           </a:p>
         </p:txBody>
       </p:sp>
@@ -2578,10 +2584,13 @@
           <a:lstStyle/>
           <a:p>
             <a:pPr indent="0" marL="0">
-              <a:buNone/>
-            </a:pPr>
-            <a:r>
-              <a:rPr lang="en-US" sz="1700" b="1" dirty="0">
+              <a:lnSpc>
+                <a:spcPct val="100000"/>
+              </a:lnSpc>
+              <a:buNone/>
+            </a:pPr>
+            <a:r>
+              <a:rPr lang="en-US" sz="1800" b="1" dirty="0">
                 <a:solidFill>
                   <a:srgbClr val="132A3A"/>
                 </a:solidFill>
@@ -2591,7 +2600,7 @@
               </a:rPr>
               <a:t>1,162.4평</a:t>
             </a:r>
-            <a:endParaRPr lang="en-US" sz="1700" dirty="0"/>
+            <a:endParaRPr lang="en-US" sz="1800" dirty="0"/>
           </a:p>
         </p:txBody>
       </p:sp>
@@ -2685,10 +2694,13 @@
           <a:lstStyle/>
           <a:p>
             <a:pPr indent="0" marL="0">
-              <a:buNone/>
-            </a:pPr>
-            <a:r>
-              <a:rPr lang="en-US" sz="1700" b="1" dirty="0">
+              <a:lnSpc>
+                <a:spcPct val="100000"/>
+              </a:lnSpc>
+              <a:buNone/>
+            </a:pPr>
+            <a:r>
+              <a:rPr lang="en-US" sz="2200" b="1" dirty="0">
                 <a:solidFill>
                   <a:srgbClr val="132A3A"/>
                 </a:solidFill>
@@ -2698,7 +2710,7 @@
               </a:rPr>
               <a:t>B2/F12</a:t>
             </a:r>
-            <a:endParaRPr lang="en-US" sz="1700" dirty="0"/>
+            <a:endParaRPr lang="en-US" sz="2200" dirty="0"/>
           </a:p>
         </p:txBody>
       </p:sp>
@@ -2792,10 +2804,13 @@
           <a:lstStyle/>
           <a:p>
             <a:pPr indent="0" marL="0">
-              <a:buNone/>
-            </a:pPr>
-            <a:r>
-              <a:rPr lang="en-US" sz="1700" b="1" dirty="0">
+              <a:lnSpc>
+                <a:spcPct val="100000"/>
+              </a:lnSpc>
+              <a:buNone/>
+            </a:pPr>
+            <a:r>
+              <a:rPr lang="en-US" sz="1400" b="1" dirty="0">
                 <a:solidFill>
                   <a:srgbClr val="132A3A"/>
                 </a:solidFill>
@@ -2805,7 +2820,7 @@
               </a:rPr>
               <a:t>만실 운영 (공실 0%)</a:t>
             </a:r>
-            <a:endParaRPr lang="en-US" sz="1700" dirty="0"/>
+            <a:endParaRPr lang="en-US" sz="1400" dirty="0"/>
           </a:p>
         </p:txBody>
       </p:sp>
@@ -2899,10 +2914,13 @@
           <a:lstStyle/>
           <a:p>
             <a:pPr indent="0" marL="0">
-              <a:buNone/>
-            </a:pPr>
-            <a:r>
-              <a:rPr lang="en-US" sz="1700" b="1" dirty="0">
+              <a:lnSpc>
+                <a:spcPct val="100000"/>
+              </a:lnSpc>
+              <a:buNone/>
+            </a:pPr>
+            <a:r>
+              <a:rPr lang="en-US" sz="1800" b="1" dirty="0">
                 <a:solidFill>
                   <a:srgbClr val="132A3A"/>
                 </a:solidFill>
@@ -2912,7 +2930,7 @@
               </a:rPr>
               <a:t>약 300억 원</a:t>
             </a:r>
-            <a:endParaRPr lang="en-US" sz="1700" dirty="0"/>
+            <a:endParaRPr lang="en-US" sz="1800" dirty="0"/>
           </a:p>
         </p:txBody>
       </p:sp>
@@ -3384,7 +3402,7 @@
                 <a:ea typeface="맑은 고딕" pitchFamily="34" charset="-122"/>
                 <a:cs typeface="맑은 고딕" pitchFamily="34" charset="-120"/>
               </a:rPr>
-              <a:t>CRE DEAL   |   </a:t>
+              <a:t>CRE DEAL</a:t>
             </a:r>
             <a:endParaRPr lang="en-US" sz="800" dirty="0"/>
           </a:p>
@@ -3646,7 +3664,7 @@
         <p:spPr>
           <a:xfrm>
             <a:off x="502920" y="1645920"/>
-            <a:ext cx="1920240" cy="347472"/>
+            <a:ext cx="1920240" cy="329184"/>
           </a:xfrm>
           <a:prstGeom prst="rect">
             <a:avLst/>
@@ -3688,7 +3706,7 @@
         <p:spPr>
           <a:xfrm>
             <a:off x="2423160" y="1645920"/>
-            <a:ext cx="4937760" cy="347472"/>
+            <a:ext cx="4937760" cy="329184"/>
           </a:xfrm>
           <a:prstGeom prst="rect">
             <a:avLst/>
@@ -3729,7 +3747,7 @@
         </p:nvSpPr>
         <p:spPr>
           <a:xfrm>
-            <a:off x="502920" y="1993392"/>
+            <a:off x="502920" y="1975104"/>
             <a:ext cx="6858000" cy="0"/>
           </a:xfrm>
           <a:prstGeom prst="line">
@@ -3752,8 +3770,8 @@
         </p:nvSpPr>
         <p:spPr>
           <a:xfrm>
-            <a:off x="502920" y="1993392"/>
-            <a:ext cx="1920240" cy="347472"/>
+            <a:off x="502920" y="1975104"/>
+            <a:ext cx="1920240" cy="329184"/>
           </a:xfrm>
           <a:prstGeom prst="rect">
             <a:avLst/>
@@ -3794,8 +3812,8 @@
         </p:nvSpPr>
         <p:spPr>
           <a:xfrm>
-            <a:off x="2423160" y="1993392"/>
-            <a:ext cx="4937760" cy="347472"/>
+            <a:off x="2423160" y="1975104"/>
+            <a:ext cx="4937760" cy="329184"/>
           </a:xfrm>
           <a:prstGeom prst="rect">
             <a:avLst/>
@@ -3836,7 +3854,7 @@
         </p:nvSpPr>
         <p:spPr>
           <a:xfrm>
-            <a:off x="502920" y="2340864"/>
+            <a:off x="502920" y="2304288"/>
             <a:ext cx="6858000" cy="0"/>
           </a:xfrm>
           <a:prstGeom prst="line">
@@ -3859,8 +3877,8 @@
         </p:nvSpPr>
         <p:spPr>
           <a:xfrm>
-            <a:off x="502920" y="2340864"/>
-            <a:ext cx="1920240" cy="347472"/>
+            <a:off x="502920" y="2304288"/>
+            <a:ext cx="1920240" cy="329184"/>
           </a:xfrm>
           <a:prstGeom prst="rect">
             <a:avLst/>
@@ -3901,8 +3919,8 @@
         </p:nvSpPr>
         <p:spPr>
           <a:xfrm>
-            <a:off x="2423160" y="2340864"/>
-            <a:ext cx="4937760" cy="347472"/>
+            <a:off x="2423160" y="2304288"/>
+            <a:ext cx="4937760" cy="329184"/>
           </a:xfrm>
           <a:prstGeom prst="rect">
             <a:avLst/>
@@ -3943,7 +3961,7 @@
         </p:nvSpPr>
         <p:spPr>
           <a:xfrm>
-            <a:off x="502920" y="2688336"/>
+            <a:off x="502920" y="2633472"/>
             <a:ext cx="6858000" cy="0"/>
           </a:xfrm>
           <a:prstGeom prst="line">
@@ -3966,8 +3984,8 @@
         </p:nvSpPr>
         <p:spPr>
           <a:xfrm>
-            <a:off x="502920" y="2688336"/>
-            <a:ext cx="1920240" cy="347472"/>
+            <a:off x="502920" y="2633472"/>
+            <a:ext cx="1920240" cy="329184"/>
           </a:xfrm>
           <a:prstGeom prst="rect">
             <a:avLst/>
@@ -4008,8 +4026,8 @@
         </p:nvSpPr>
         <p:spPr>
           <a:xfrm>
-            <a:off x="2423160" y="2688336"/>
-            <a:ext cx="4937760" cy="347472"/>
+            <a:off x="2423160" y="2633472"/>
+            <a:ext cx="4937760" cy="329184"/>
           </a:xfrm>
           <a:prstGeom prst="rect">
             <a:avLst/>
@@ -4050,7 +4068,7 @@
         </p:nvSpPr>
         <p:spPr>
           <a:xfrm>
-            <a:off x="502920" y="3035808"/>
+            <a:off x="502920" y="2962656"/>
             <a:ext cx="6858000" cy="0"/>
           </a:xfrm>
           <a:prstGeom prst="line">
@@ -4073,8 +4091,8 @@
         </p:nvSpPr>
         <p:spPr>
           <a:xfrm>
-            <a:off x="502920" y="3035808"/>
-            <a:ext cx="1920240" cy="347472"/>
+            <a:off x="502920" y="2962656"/>
+            <a:ext cx="1920240" cy="329184"/>
           </a:xfrm>
           <a:prstGeom prst="rect">
             <a:avLst/>
@@ -4115,8 +4133,8 @@
         </p:nvSpPr>
         <p:spPr>
           <a:xfrm>
-            <a:off x="2423160" y="3035808"/>
-            <a:ext cx="4937760" cy="347472"/>
+            <a:off x="2423160" y="2962656"/>
+            <a:ext cx="4937760" cy="329184"/>
           </a:xfrm>
           <a:prstGeom prst="rect">
             <a:avLst/>
@@ -4157,7 +4175,7 @@
         </p:nvSpPr>
         <p:spPr>
           <a:xfrm>
-            <a:off x="502920" y="3383280"/>
+            <a:off x="502920" y="3291840"/>
             <a:ext cx="6858000" cy="0"/>
           </a:xfrm>
           <a:prstGeom prst="line">
@@ -4180,8 +4198,8 @@
         </p:nvSpPr>
         <p:spPr>
           <a:xfrm>
-            <a:off x="502920" y="3383280"/>
-            <a:ext cx="1920240" cy="347472"/>
+            <a:off x="502920" y="3291840"/>
+            <a:ext cx="1920240" cy="329184"/>
           </a:xfrm>
           <a:prstGeom prst="rect">
             <a:avLst/>
@@ -4222,8 +4240,8 @@
         </p:nvSpPr>
         <p:spPr>
           <a:xfrm>
-            <a:off x="2423160" y="3383280"/>
-            <a:ext cx="4937760" cy="347472"/>
+            <a:off x="2423160" y="3291840"/>
+            <a:ext cx="4937760" cy="329184"/>
           </a:xfrm>
           <a:prstGeom prst="rect">
             <a:avLst/>
@@ -4264,7 +4282,7 @@
         </p:nvSpPr>
         <p:spPr>
           <a:xfrm>
-            <a:off x="502920" y="3730752"/>
+            <a:off x="502920" y="3621024"/>
             <a:ext cx="6858000" cy="0"/>
           </a:xfrm>
           <a:prstGeom prst="line">
@@ -4287,8 +4305,8 @@
         </p:nvSpPr>
         <p:spPr>
           <a:xfrm>
-            <a:off x="502920" y="3730752"/>
-            <a:ext cx="1920240" cy="347472"/>
+            <a:off x="502920" y="3621024"/>
+            <a:ext cx="1920240" cy="329184"/>
           </a:xfrm>
           <a:prstGeom prst="rect">
             <a:avLst/>
@@ -4329,8 +4347,8 @@
         </p:nvSpPr>
         <p:spPr>
           <a:xfrm>
-            <a:off x="2423160" y="3730752"/>
-            <a:ext cx="4937760" cy="347472"/>
+            <a:off x="2423160" y="3621024"/>
+            <a:ext cx="4937760" cy="329184"/>
           </a:xfrm>
           <a:prstGeom prst="rect">
             <a:avLst/>
@@ -4371,7 +4389,7 @@
         </p:nvSpPr>
         <p:spPr>
           <a:xfrm>
-            <a:off x="502920" y="4078224"/>
+            <a:off x="502920" y="3950208"/>
             <a:ext cx="6858000" cy="0"/>
           </a:xfrm>
           <a:prstGeom prst="line">
@@ -4394,8 +4412,8 @@
         </p:nvSpPr>
         <p:spPr>
           <a:xfrm>
-            <a:off x="502920" y="4078224"/>
-            <a:ext cx="1920240" cy="347472"/>
+            <a:off x="502920" y="3950208"/>
+            <a:ext cx="1920240" cy="329184"/>
           </a:xfrm>
           <a:prstGeom prst="rect">
             <a:avLst/>
@@ -4436,8 +4454,8 @@
         </p:nvSpPr>
         <p:spPr>
           <a:xfrm>
-            <a:off x="2423160" y="4078224"/>
-            <a:ext cx="4937760" cy="347472"/>
+            <a:off x="2423160" y="3950208"/>
+            <a:ext cx="4937760" cy="329184"/>
           </a:xfrm>
           <a:prstGeom prst="rect">
             <a:avLst/>
@@ -4478,7 +4496,7 @@
         </p:nvSpPr>
         <p:spPr>
           <a:xfrm>
-            <a:off x="502920" y="4517136"/>
+            <a:off x="502920" y="4389120"/>
             <a:ext cx="6858000" cy="1005840"/>
           </a:xfrm>
           <a:prstGeom prst="rect">
@@ -4503,7 +4521,7 @@
         </p:nvSpPr>
         <p:spPr>
           <a:xfrm>
-            <a:off x="685800" y="4517136"/>
+            <a:off x="685800" y="4389120"/>
             <a:ext cx="2726741" cy="502920"/>
           </a:xfrm>
           <a:prstGeom prst="rect">
@@ -4542,7 +4560,7 @@
         </p:nvSpPr>
         <p:spPr>
           <a:xfrm>
-            <a:off x="3412541" y="4517136"/>
+            <a:off x="3412541" y="4389120"/>
             <a:ext cx="3765499" cy="502920"/>
           </a:xfrm>
           <a:prstGeom prst="rect">
@@ -4581,7 +4599,7 @@
         </p:nvSpPr>
         <p:spPr>
           <a:xfrm>
-            <a:off x="640080" y="5020056"/>
+            <a:off x="640080" y="4892040"/>
             <a:ext cx="6583680" cy="0"/>
           </a:xfrm>
           <a:prstGeom prst="line">
@@ -4604,7 +4622,7 @@
         </p:nvSpPr>
         <p:spPr>
           <a:xfrm>
-            <a:off x="685800" y="5020056"/>
+            <a:off x="685800" y="4892040"/>
             <a:ext cx="2726741" cy="457200"/>
           </a:xfrm>
           <a:prstGeom prst="rect">
@@ -4643,7 +4661,7 @@
         </p:nvSpPr>
         <p:spPr>
           <a:xfrm>
-            <a:off x="3412541" y="5020056"/>
+            <a:off x="3412541" y="4892040"/>
             <a:ext cx="3765499" cy="457200"/>
           </a:xfrm>
           <a:prstGeom prst="rect">
@@ -4815,7 +4833,55 @@
                 <a:ea typeface="맑은 고딕" pitchFamily="34" charset="-122"/>
                 <a:cs typeface="맑은 고딕" pitchFamily="34" charset="-120"/>
               </a:rPr>
-              <a:t>투자 검토 대상 상업용 자산\n• 권리관계 및 임대차 현황 실사 확인 필요\n• 상세 인접 인프라 및 입지 환경 분석 권장</a:t>
+              <a:t>투자 검토 대상 상업용 자산</a:t>
+            </a:r>
+            <a:endParaRPr lang="en-US" sz="980" dirty="0"/>
+          </a:p>
+          <a:p>
+            <a:pPr marL="342900" indent="-342900">
+              <a:lnSpc>
+                <a:spcPct val="108000"/>
+              </a:lnSpc>
+              <a:spcBef>
+                <a:spcPts val="300"/>
+              </a:spcBef>
+              <a:buSzPct val="100000"/>
+              <a:buChar char="•"/>
+            </a:pPr>
+            <a:r>
+              <a:rPr lang="en-US" sz="980" dirty="0">
+                <a:solidFill>
+                  <a:srgbClr val="2B2B2B"/>
+                </a:solidFill>
+                <a:latin typeface="맑은 고딕" pitchFamily="34" charset="0"/>
+                <a:ea typeface="맑은 고딕" pitchFamily="34" charset="-122"/>
+                <a:cs typeface="맑은 고딕" pitchFamily="34" charset="-120"/>
+              </a:rPr>
+              <a:t>권리관계 및 임대차 계약 구조 분석</a:t>
+            </a:r>
+            <a:endParaRPr lang="en-US" sz="980" dirty="0"/>
+          </a:p>
+          <a:p>
+            <a:pPr marL="342900" indent="-342900">
+              <a:lnSpc>
+                <a:spcPct val="108000"/>
+              </a:lnSpc>
+              <a:spcBef>
+                <a:spcPts val="300"/>
+              </a:spcBef>
+              <a:buSzPct val="100000"/>
+              <a:buChar char="•"/>
+            </a:pPr>
+            <a:r>
+              <a:rPr lang="en-US" sz="980" dirty="0">
+                <a:solidFill>
+                  <a:srgbClr val="2B2B2B"/>
+                </a:solidFill>
+                <a:latin typeface="맑은 고딕" pitchFamily="34" charset="0"/>
+                <a:ea typeface="맑은 고딕" pitchFamily="34" charset="-122"/>
+                <a:cs typeface="맑은 고딕" pitchFamily="34" charset="-120"/>
+              </a:rPr>
+              <a:t>상세 인접 인프라 및 입지 환경 분석</a:t>
             </a:r>
             <a:endParaRPr lang="en-US" sz="980" dirty="0"/>
           </a:p>
@@ -4939,7 +5005,55 @@
                 <a:ea typeface="맑은 고딕" pitchFamily="34" charset="-122"/>
                 <a:cs typeface="맑은 고딕" pitchFamily="34" charset="-120"/>
               </a:rPr>
-              <a:t>투자 검토 대상 자산\n• 임대차 계약 현황 및 운영비 실사 확인 필요\n• 매입 후 운용 계획에 따른 수익성 분석 권장</a:t>
+              <a:t>투자 검토 대상 자산</a:t>
+            </a:r>
+            <a:endParaRPr lang="en-US" sz="980" dirty="0"/>
+          </a:p>
+          <a:p>
+            <a:pPr marL="342900" indent="-342900">
+              <a:lnSpc>
+                <a:spcPct val="108000"/>
+              </a:lnSpc>
+              <a:spcBef>
+                <a:spcPts val="300"/>
+              </a:spcBef>
+              <a:buSzPct val="100000"/>
+              <a:buChar char="•"/>
+            </a:pPr>
+            <a:r>
+              <a:rPr lang="en-US" sz="980" dirty="0">
+                <a:solidFill>
+                  <a:srgbClr val="2B2B2B"/>
+                </a:solidFill>
+                <a:latin typeface="맑은 고딕" pitchFamily="34" charset="0"/>
+                <a:ea typeface="맑은 고딕" pitchFamily="34" charset="-122"/>
+                <a:cs typeface="맑은 고딕" pitchFamily="34" charset="-120"/>
+              </a:rPr>
+              <a:t>임대차 계약 조건 및 운영비 구조 분석</a:t>
+            </a:r>
+            <a:endParaRPr lang="en-US" sz="980" dirty="0"/>
+          </a:p>
+          <a:p>
+            <a:pPr marL="342900" indent="-342900">
+              <a:lnSpc>
+                <a:spcPct val="108000"/>
+              </a:lnSpc>
+              <a:spcBef>
+                <a:spcPts val="300"/>
+              </a:spcBef>
+              <a:buSzPct val="100000"/>
+              <a:buChar char="•"/>
+            </a:pPr>
+            <a:r>
+              <a:rPr lang="en-US" sz="980" dirty="0">
+                <a:solidFill>
+                  <a:srgbClr val="2B2B2B"/>
+                </a:solidFill>
+                <a:latin typeface="맑은 고딕" pitchFamily="34" charset="0"/>
+                <a:ea typeface="맑은 고딕" pitchFamily="34" charset="-122"/>
+                <a:cs typeface="맑은 고딕" pitchFamily="34" charset="-120"/>
+              </a:rPr>
+              <a:t>매입 후 운용 계획에 따른 수익성 분석</a:t>
             </a:r>
             <a:endParaRPr lang="en-US" sz="980" dirty="0"/>
           </a:p>
@@ -4978,7 +5092,7 @@
                 <a:ea typeface="맑은 고딕" pitchFamily="34" charset="-122"/>
                 <a:cs typeface="맑은 고딕" pitchFamily="34" charset="-120"/>
               </a:rPr>
-              <a:t>CRE DEAL   |   </a:t>
+              <a:t>CRE DEAL</a:t>
             </a:r>
             <a:endParaRPr lang="en-US" sz="800" dirty="0"/>
           </a:p>
@@ -5264,7 +5378,7 @@
         <p:spPr>
           <a:xfrm>
             <a:off x="5989320" y="1801368"/>
-            <a:ext cx="1560003" cy="493776"/>
+            <a:ext cx="1560003" cy="457200"/>
           </a:xfrm>
           <a:prstGeom prst="rect">
             <a:avLst/>
@@ -5283,7 +5397,7 @@
               <a:buNone/>
             </a:pPr>
             <a:r>
-              <a:rPr lang="en-US" sz="1300" dirty="0">
+              <a:rPr lang="en-US" sz="1250" dirty="0">
                 <a:solidFill>
                   <a:srgbClr val="5B6B73"/>
                 </a:solidFill>
@@ -5291,9 +5405,9 @@
                 <a:ea typeface="맑은 고딕" pitchFamily="34" charset="-122"/>
                 <a:cs typeface="맑은 고딕" pitchFamily="34" charset="-120"/>
               </a:rPr>
-              <a:t>대중교통</a:t>
-            </a:r>
-            <a:endParaRPr lang="en-US" sz="1300" dirty="0"/>
+              <a:t>소재지</a:t>
+            </a:r>
+            <a:endParaRPr lang="en-US" sz="1250" dirty="0"/>
           </a:p>
         </p:txBody>
       </p:sp>
@@ -5306,7 +5420,7 @@
         <p:spPr>
           <a:xfrm>
             <a:off x="7549323" y="1801368"/>
-            <a:ext cx="4011436" cy="493776"/>
+            <a:ext cx="4011436" cy="457200"/>
           </a:xfrm>
           <a:prstGeom prst="rect">
             <a:avLst/>
@@ -5325,7 +5439,7 @@
               <a:buNone/>
             </a:pPr>
             <a:r>
-              <a:rPr lang="en-US" sz="1300" b="1" dirty="0">
+              <a:rPr lang="en-US" sz="1250" b="1" dirty="0">
                 <a:solidFill>
                   <a:srgbClr val="132A3A"/>
                 </a:solidFill>
@@ -5333,9 +5447,9 @@
                 <a:ea typeface="맑은 고딕" pitchFamily="34" charset="-122"/>
                 <a:cs typeface="맑은 고딕" pitchFamily="34" charset="-120"/>
               </a:rPr>
-              <a:t>인접 지하철역 역세권 (상세 확인 필요)</a:t>
-            </a:r>
-            <a:endParaRPr lang="en-US" sz="1300" dirty="0"/>
+              <a:t>서울특별시 서대문구 대현동 56-1</a:t>
+            </a:r>
+            <a:endParaRPr lang="en-US" sz="1250" dirty="0"/>
           </a:p>
         </p:txBody>
       </p:sp>
@@ -5347,7 +5461,7 @@
         </p:nvSpPr>
         <p:spPr>
           <a:xfrm>
-            <a:off x="5989320" y="2295144"/>
+            <a:off x="5989320" y="2258568"/>
             <a:ext cx="5571439" cy="0"/>
           </a:xfrm>
           <a:prstGeom prst="line">
@@ -5370,8 +5484,8 @@
         </p:nvSpPr>
         <p:spPr>
           <a:xfrm>
-            <a:off x="5989320" y="2295144"/>
-            <a:ext cx="1560003" cy="493776"/>
+            <a:off x="5989320" y="2258568"/>
+            <a:ext cx="1560003" cy="457200"/>
           </a:xfrm>
           <a:prstGeom prst="rect">
             <a:avLst/>
@@ -5390,7 +5504,7 @@
               <a:buNone/>
             </a:pPr>
             <a:r>
-              <a:rPr lang="en-US" sz="1300" dirty="0">
+              <a:rPr lang="en-US" sz="1250" dirty="0">
                 <a:solidFill>
                   <a:srgbClr val="5B6B73"/>
                 </a:solidFill>
@@ -5398,9 +5512,9 @@
                 <a:ea typeface="맑은 고딕" pitchFamily="34" charset="-122"/>
                 <a:cs typeface="맑은 고딕" pitchFamily="34" charset="-120"/>
               </a:rPr>
-              <a:t>상권권역</a:t>
-            </a:r>
-            <a:endParaRPr lang="en-US" sz="1300" dirty="0"/>
+              <a:t>대중교통</a:t>
+            </a:r>
+            <a:endParaRPr lang="en-US" sz="1250" dirty="0"/>
           </a:p>
         </p:txBody>
       </p:sp>
@@ -5412,8 +5526,8 @@
         </p:nvSpPr>
         <p:spPr>
           <a:xfrm>
-            <a:off x="7549323" y="2295144"/>
-            <a:ext cx="4011436" cy="493776"/>
+            <a:off x="7549323" y="2258568"/>
+            <a:ext cx="4011436" cy="457200"/>
           </a:xfrm>
           <a:prstGeom prst="rect">
             <a:avLst/>
@@ -5432,7 +5546,7 @@
               <a:buNone/>
             </a:pPr>
             <a:r>
-              <a:rPr lang="en-US" sz="1300" b="1" dirty="0">
+              <a:rPr lang="en-US" sz="1250" b="1" dirty="0">
                 <a:solidFill>
                   <a:srgbClr val="132A3A"/>
                 </a:solidFill>
@@ -5440,9 +5554,9 @@
                 <a:ea typeface="맑은 고딕" pitchFamily="34" charset="-122"/>
                 <a:cs typeface="맑은 고딕" pitchFamily="34" charset="-120"/>
               </a:rPr>
-              <a:t>300억 주요 상업·업무 권역</a:t>
-            </a:r>
-            <a:endParaRPr lang="en-US" sz="1300" dirty="0"/>
+              <a:t>지하철 및 간선버스 인접</a:t>
+            </a:r>
+            <a:endParaRPr lang="en-US" sz="1250" dirty="0"/>
           </a:p>
         </p:txBody>
       </p:sp>
@@ -5454,7 +5568,114 @@
         </p:nvSpPr>
         <p:spPr>
           <a:xfrm>
-            <a:off x="5989320" y="2926080"/>
+            <a:off x="5989320" y="2715768"/>
+            <a:ext cx="5571439" cy="0"/>
+          </a:xfrm>
+          <a:prstGeom prst="line">
+            <a:avLst/>
+          </a:prstGeom>
+          <a:noFill/>
+          <a:ln w="3810">
+            <a:solidFill>
+              <a:srgbClr val="CBD5E0"/>
+            </a:solidFill>
+            <a:prstDash val="solid"/>
+          </a:ln>
+        </p:spPr>
+      </p:sp>
+      <p:sp>
+        <p:nvSpPr>
+          <p:cNvPr id="14" name="Text 11"/>
+          <p:cNvSpPr/>
+          <p:nvPr/>
+        </p:nvSpPr>
+        <p:spPr>
+          <a:xfrm>
+            <a:off x="5989320" y="2715768"/>
+            <a:ext cx="1560003" cy="457200"/>
+          </a:xfrm>
+          <a:prstGeom prst="rect">
+            <a:avLst/>
+          </a:prstGeom>
+          <a:noFill/>
+          <a:ln/>
+        </p:spPr>
+        <p:txBody>
+          <a:bodyPr wrap="square" lIns="0" tIns="0" rIns="0" bIns="0" rtlCol="0" anchor="ctr"/>
+          <a:lstStyle/>
+          <a:p>
+            <a:pPr indent="0" marL="0">
+              <a:lnSpc>
+                <a:spcPct val="115000"/>
+              </a:lnSpc>
+              <a:buNone/>
+            </a:pPr>
+            <a:r>
+              <a:rPr lang="en-US" sz="1250" dirty="0">
+                <a:solidFill>
+                  <a:srgbClr val="5B6B73"/>
+                </a:solidFill>
+                <a:latin typeface="맑은 고딕" pitchFamily="34" charset="0"/>
+                <a:ea typeface="맑은 고딕" pitchFamily="34" charset="-122"/>
+                <a:cs typeface="맑은 고딕" pitchFamily="34" charset="-120"/>
+              </a:rPr>
+              <a:t>상권권역</a:t>
+            </a:r>
+            <a:endParaRPr lang="en-US" sz="1250" dirty="0"/>
+          </a:p>
+        </p:txBody>
+      </p:sp>
+      <p:sp>
+        <p:nvSpPr>
+          <p:cNvPr id="15" name="Text 12"/>
+          <p:cNvSpPr/>
+          <p:nvPr/>
+        </p:nvSpPr>
+        <p:spPr>
+          <a:xfrm>
+            <a:off x="7549323" y="2715768"/>
+            <a:ext cx="4011436" cy="457200"/>
+          </a:xfrm>
+          <a:prstGeom prst="rect">
+            <a:avLst/>
+          </a:prstGeom>
+          <a:noFill/>
+          <a:ln/>
+        </p:spPr>
+        <p:txBody>
+          <a:bodyPr wrap="square" lIns="0" tIns="0" rIns="0" bIns="0" rtlCol="0" anchor="ctr"/>
+          <a:lstStyle/>
+          <a:p>
+            <a:pPr indent="0" marL="0">
+              <a:lnSpc>
+                <a:spcPct val="115000"/>
+              </a:lnSpc>
+              <a:buNone/>
+            </a:pPr>
+            <a:r>
+              <a:rPr lang="en-US" sz="1250" b="1" dirty="0">
+                <a:solidFill>
+                  <a:srgbClr val="132A3A"/>
+                </a:solidFill>
+                <a:latin typeface="맑은 고딕" pitchFamily="34" charset="0"/>
+                <a:ea typeface="맑은 고딕" pitchFamily="34" charset="-122"/>
+                <a:cs typeface="맑은 고딕" pitchFamily="34" charset="-120"/>
+              </a:rPr>
+              <a:t>서대문구 대현동 주요 상업·업무 권역</a:t>
+            </a:r>
+            <a:endParaRPr lang="en-US" sz="1250" dirty="0"/>
+          </a:p>
+        </p:txBody>
+      </p:sp>
+      <p:sp>
+        <p:nvSpPr>
+          <p:cNvPr id="16" name="Shape 13"/>
+          <p:cNvSpPr/>
+          <p:nvPr/>
+        </p:nvSpPr>
+        <p:spPr>
+          <a:xfrm>
+            <a:off x="5989320" y="3282696"/>
             <a:ext cx="5571439" cy="658368"/>
           </a:xfrm>
           <a:prstGeom prst="roundRect">
@@ -5470,13 +5691,13 @@
       </p:sp>
       <p:sp>
         <p:nvSpPr>
-          <p:cNvPr id="14" name="Shape 11"/>
-          <p:cNvSpPr/>
-          <p:nvPr/>
-        </p:nvSpPr>
-        <p:spPr>
-          <a:xfrm>
-            <a:off x="5989320" y="2980944"/>
+          <p:cNvPr id="17" name="Shape 14"/>
+          <p:cNvSpPr/>
+          <p:nvPr/>
+        </p:nvSpPr>
+        <p:spPr>
+          <a:xfrm>
+            <a:off x="5989320" y="3337560"/>
             <a:ext cx="36576" cy="548640"/>
           </a:xfrm>
           <a:prstGeom prst="rect">
@@ -5490,13 +5711,13 @@
       </p:sp>
       <p:sp>
         <p:nvSpPr>
-          <p:cNvPr id="15" name="Text 12"/>
-          <p:cNvSpPr/>
-          <p:nvPr/>
-        </p:nvSpPr>
-        <p:spPr>
-          <a:xfrm>
-            <a:off x="6135624" y="3017520"/>
+          <p:cNvPr id="18" name="Text 15"/>
+          <p:cNvSpPr/>
+          <p:nvPr/>
+        </p:nvSpPr>
+        <p:spPr>
+          <a:xfrm>
+            <a:off x="6135624" y="3374136"/>
             <a:ext cx="5315407" cy="201168"/>
           </a:xfrm>
           <a:prstGeom prst="rect">
@@ -5529,13 +5750,13 @@
       </p:sp>
       <p:sp>
         <p:nvSpPr>
-          <p:cNvPr id="16" name="Text 13"/>
-          <p:cNvSpPr/>
-          <p:nvPr/>
-        </p:nvSpPr>
-        <p:spPr>
-          <a:xfrm>
-            <a:off x="6135624" y="3218688"/>
+          <p:cNvPr id="19" name="Text 16"/>
+          <p:cNvSpPr/>
+          <p:nvPr/>
+        </p:nvSpPr>
+        <p:spPr>
+          <a:xfrm>
+            <a:off x="6135624" y="3575304"/>
             <a:ext cx="5315407" cy="329184"/>
           </a:xfrm>
           <a:prstGeom prst="rect">
@@ -5564,7 +5785,7 @@
                 <a:ea typeface="맑은 고딕" pitchFamily="34" charset="-122"/>
                 <a:cs typeface="맑은 고딕" pitchFamily="34" charset="-120"/>
               </a:rPr>
-              <a:t>300억 배후 상권 기반 안정적 임대 수요</a:t>
+              <a:t>서대문구 대현동 배후 상권 기반 안정적 임대 수요</a:t>
             </a:r>
             <a:endParaRPr lang="en-US" sz="980" dirty="0"/>
           </a:p>
@@ -5572,7 +5793,7 @@
       </p:sp>
       <p:sp>
         <p:nvSpPr>
-          <p:cNvPr id="17" name="Text 14"/>
+          <p:cNvPr id="20" name="Text 17"/>
           <p:cNvSpPr/>
           <p:nvPr/>
         </p:nvSpPr>
@@ -5603,7 +5824,7 @@
                 <a:ea typeface="맑은 고딕" pitchFamily="34" charset="-122"/>
                 <a:cs typeface="맑은 고딕" pitchFamily="34" charset="-120"/>
               </a:rPr>
-              <a:t>CRE DEAL   |   </a:t>
+              <a:t>CRE DEAL</a:t>
             </a:r>
             <a:endParaRPr lang="en-US" sz="800" dirty="0"/>
           </a:p>
@@ -5611,7 +5832,7 @@
       </p:sp>
       <p:sp>
         <p:nvSpPr>
-          <p:cNvPr id="18" name="Text 15"/>
+          <p:cNvPr id="21" name="Text 18"/>
           <p:cNvSpPr/>
           <p:nvPr/>
         </p:nvSpPr>
@@ -5865,7 +6086,7 @@
         <p:spPr>
           <a:xfrm>
             <a:off x="502920" y="1645920"/>
-            <a:ext cx="1920240" cy="420624"/>
+            <a:ext cx="1920240" cy="402336"/>
           </a:xfrm>
           <a:prstGeom prst="rect">
             <a:avLst/>
@@ -5907,7 +6128,7 @@
         <p:spPr>
           <a:xfrm>
             <a:off x="2423160" y="1645920"/>
-            <a:ext cx="4937760" cy="420624"/>
+            <a:ext cx="4937760" cy="402336"/>
           </a:xfrm>
           <a:prstGeom prst="rect">
             <a:avLst/>
@@ -5948,7 +6169,7 @@
         </p:nvSpPr>
         <p:spPr>
           <a:xfrm>
-            <a:off x="502920" y="2066544"/>
+            <a:off x="502920" y="2048256"/>
             <a:ext cx="6858000" cy="0"/>
           </a:xfrm>
           <a:prstGeom prst="line">
@@ -5971,8 +6192,8 @@
         </p:nvSpPr>
         <p:spPr>
           <a:xfrm>
-            <a:off x="502920" y="2066544"/>
-            <a:ext cx="1920240" cy="420624"/>
+            <a:off x="502920" y="2048256"/>
+            <a:ext cx="1920240" cy="402336"/>
           </a:xfrm>
           <a:prstGeom prst="rect">
             <a:avLst/>
@@ -6013,8 +6234,8 @@
         </p:nvSpPr>
         <p:spPr>
           <a:xfrm>
-            <a:off x="2423160" y="2066544"/>
-            <a:ext cx="4937760" cy="420624"/>
+            <a:off x="2423160" y="2048256"/>
+            <a:ext cx="4937760" cy="402336"/>
           </a:xfrm>
           <a:prstGeom prst="rect">
             <a:avLst/>
@@ -6055,7 +6276,7 @@
         </p:nvSpPr>
         <p:spPr>
           <a:xfrm>
-            <a:off x="502920" y="2487168"/>
+            <a:off x="502920" y="2450592"/>
             <a:ext cx="6858000" cy="0"/>
           </a:xfrm>
           <a:prstGeom prst="line">
@@ -6078,8 +6299,8 @@
         </p:nvSpPr>
         <p:spPr>
           <a:xfrm>
-            <a:off x="502920" y="2487168"/>
-            <a:ext cx="1920240" cy="420624"/>
+            <a:off x="502920" y="2450592"/>
+            <a:ext cx="1920240" cy="402336"/>
           </a:xfrm>
           <a:prstGeom prst="rect">
             <a:avLst/>
@@ -6120,8 +6341,8 @@
         </p:nvSpPr>
         <p:spPr>
           <a:xfrm>
-            <a:off x="2423160" y="2487168"/>
-            <a:ext cx="4937760" cy="420624"/>
+            <a:off x="2423160" y="2450592"/>
+            <a:ext cx="4937760" cy="402336"/>
           </a:xfrm>
           <a:prstGeom prst="rect">
             <a:avLst/>
@@ -6162,7 +6383,7 @@
         </p:nvSpPr>
         <p:spPr>
           <a:xfrm>
-            <a:off x="502920" y="2907792"/>
+            <a:off x="502920" y="2852928"/>
             <a:ext cx="6858000" cy="0"/>
           </a:xfrm>
           <a:prstGeom prst="line">
@@ -6185,8 +6406,8 @@
         </p:nvSpPr>
         <p:spPr>
           <a:xfrm>
-            <a:off x="502920" y="2907792"/>
-            <a:ext cx="1920240" cy="420624"/>
+            <a:off x="502920" y="2852928"/>
+            <a:ext cx="1920240" cy="402336"/>
           </a:xfrm>
           <a:prstGeom prst="rect">
             <a:avLst/>
@@ -6227,8 +6448,8 @@
         </p:nvSpPr>
         <p:spPr>
           <a:xfrm>
-            <a:off x="2423160" y="2907792"/>
-            <a:ext cx="4937760" cy="420624"/>
+            <a:off x="2423160" y="2852928"/>
+            <a:ext cx="4937760" cy="402336"/>
           </a:xfrm>
           <a:prstGeom prst="rect">
             <a:avLst/>
@@ -6269,7 +6490,7 @@
         </p:nvSpPr>
         <p:spPr>
           <a:xfrm>
-            <a:off x="502920" y="3328416"/>
+            <a:off x="502920" y="3255264"/>
             <a:ext cx="6858000" cy="0"/>
           </a:xfrm>
           <a:prstGeom prst="line">
@@ -6292,8 +6513,8 @@
         </p:nvSpPr>
         <p:spPr>
           <a:xfrm>
-            <a:off x="502920" y="3328416"/>
-            <a:ext cx="1920240" cy="420624"/>
+            <a:off x="502920" y="3255264"/>
+            <a:ext cx="1920240" cy="402336"/>
           </a:xfrm>
           <a:prstGeom prst="rect">
             <a:avLst/>
@@ -6320,7 +6541,7 @@
                 <a:ea typeface="맑은 고딕" pitchFamily="34" charset="-122"/>
                 <a:cs typeface="맑은 고딕" pitchFamily="34" charset="-120"/>
               </a:rPr>
-              <a:t>필지 형상</a:t>
+              <a:t>지목</a:t>
             </a:r>
             <a:endParaRPr lang="en-US" sz="1350" dirty="0"/>
           </a:p>
@@ -6334,8 +6555,8 @@
         </p:nvSpPr>
         <p:spPr>
           <a:xfrm>
-            <a:off x="2423160" y="3328416"/>
-            <a:ext cx="4937760" cy="420624"/>
+            <a:off x="2423160" y="3255264"/>
+            <a:ext cx="4937760" cy="402336"/>
           </a:xfrm>
           <a:prstGeom prst="rect">
             <a:avLst/>
@@ -6362,7 +6583,7 @@
                 <a:ea typeface="맑은 고딕" pitchFamily="34" charset="-122"/>
                 <a:cs typeface="맑은 고딕" pitchFamily="34" charset="-120"/>
               </a:rPr>
-              <a:t>[필지 형상 확인 필요]</a:t>
+              <a:t>대</a:t>
             </a:r>
             <a:endParaRPr lang="en-US" sz="1350" dirty="0"/>
           </a:p>
@@ -6376,7 +6597,7 @@
         </p:nvSpPr>
         <p:spPr>
           <a:xfrm>
-            <a:off x="502920" y="3749040"/>
+            <a:off x="502920" y="3657600"/>
             <a:ext cx="6858000" cy="0"/>
           </a:xfrm>
           <a:prstGeom prst="line">
@@ -6399,8 +6620,8 @@
         </p:nvSpPr>
         <p:spPr>
           <a:xfrm>
-            <a:off x="502920" y="3749040"/>
-            <a:ext cx="1920240" cy="420624"/>
+            <a:off x="502920" y="3657600"/>
+            <a:ext cx="1920240" cy="402336"/>
           </a:xfrm>
           <a:prstGeom prst="rect">
             <a:avLst/>
@@ -6427,7 +6648,7 @@
                 <a:ea typeface="맑은 고딕" pitchFamily="34" charset="-122"/>
                 <a:cs typeface="맑은 고딕" pitchFamily="34" charset="-120"/>
               </a:rPr>
-              <a:t>지목</a:t>
+              <a:t>토지평당가</a:t>
             </a:r>
             <a:endParaRPr lang="en-US" sz="1350" dirty="0"/>
           </a:p>
@@ -6441,8 +6662,8 @@
         </p:nvSpPr>
         <p:spPr>
           <a:xfrm>
-            <a:off x="2423160" y="3749040"/>
-            <a:ext cx="4937760" cy="420624"/>
+            <a:off x="2423160" y="3657600"/>
+            <a:ext cx="4937760" cy="402336"/>
           </a:xfrm>
           <a:prstGeom prst="rect">
             <a:avLst/>
@@ -6469,7 +6690,7 @@
                 <a:ea typeface="맑은 고딕" pitchFamily="34" charset="-122"/>
                 <a:cs typeface="맑은 고딕" pitchFamily="34" charset="-120"/>
               </a:rPr>
-              <a:t>대</a:t>
+              <a:t>약 20,398만 원/평</a:t>
             </a:r>
             <a:endParaRPr lang="en-US" sz="1350" dirty="0"/>
           </a:p>
@@ -6478,113 +6699,6 @@
       <p:sp>
         <p:nvSpPr>
           <p:cNvPr id="24" name="Shape 22"/>
-          <p:cNvSpPr/>
-          <p:nvPr/>
-        </p:nvSpPr>
-        <p:spPr>
-          <a:xfrm>
-            <a:off x="502920" y="4169664"/>
-            <a:ext cx="6858000" cy="0"/>
-          </a:xfrm>
-          <a:prstGeom prst="line">
-            <a:avLst/>
-          </a:prstGeom>
-          <a:noFill/>
-          <a:ln w="3810">
-            <a:solidFill>
-              <a:srgbClr val="CBD5E0"/>
-            </a:solidFill>
-            <a:prstDash val="solid"/>
-          </a:ln>
-        </p:spPr>
-      </p:sp>
-      <p:sp>
-        <p:nvSpPr>
-          <p:cNvPr id="25" name="Text 23"/>
-          <p:cNvSpPr/>
-          <p:nvPr/>
-        </p:nvSpPr>
-        <p:spPr>
-          <a:xfrm>
-            <a:off x="502920" y="4169664"/>
-            <a:ext cx="1920240" cy="420624"/>
-          </a:xfrm>
-          <a:prstGeom prst="rect">
-            <a:avLst/>
-          </a:prstGeom>
-          <a:noFill/>
-          <a:ln/>
-        </p:spPr>
-        <p:txBody>
-          <a:bodyPr wrap="square" lIns="0" tIns="0" rIns="0" bIns="0" rtlCol="0" anchor="ctr"/>
-          <a:lstStyle/>
-          <a:p>
-            <a:pPr indent="0" marL="0">
-              <a:lnSpc>
-                <a:spcPct val="115000"/>
-              </a:lnSpc>
-              <a:buNone/>
-            </a:pPr>
-            <a:r>
-              <a:rPr lang="en-US" sz="1350" dirty="0">
-                <a:solidFill>
-                  <a:srgbClr val="5B6B73"/>
-                </a:solidFill>
-                <a:latin typeface="맑은 고딕" pitchFamily="34" charset="0"/>
-                <a:ea typeface="맑은 고딕" pitchFamily="34" charset="-122"/>
-                <a:cs typeface="맑은 고딕" pitchFamily="34" charset="-120"/>
-              </a:rPr>
-              <a:t>토지평당가</a:t>
-            </a:r>
-            <a:endParaRPr lang="en-US" sz="1350" dirty="0"/>
-          </a:p>
-        </p:txBody>
-      </p:sp>
-      <p:sp>
-        <p:nvSpPr>
-          <p:cNvPr id="26" name="Text 24"/>
-          <p:cNvSpPr/>
-          <p:nvPr/>
-        </p:nvSpPr>
-        <p:spPr>
-          <a:xfrm>
-            <a:off x="2423160" y="4169664"/>
-            <a:ext cx="4937760" cy="420624"/>
-          </a:xfrm>
-          <a:prstGeom prst="rect">
-            <a:avLst/>
-          </a:prstGeom>
-          <a:noFill/>
-          <a:ln/>
-        </p:spPr>
-        <p:txBody>
-          <a:bodyPr wrap="square" lIns="0" tIns="0" rIns="0" bIns="0" rtlCol="0" anchor="ctr"/>
-          <a:lstStyle/>
-          <a:p>
-            <a:pPr indent="0" marL="0">
-              <a:lnSpc>
-                <a:spcPct val="115000"/>
-              </a:lnSpc>
-              <a:buNone/>
-            </a:pPr>
-            <a:r>
-              <a:rPr lang="en-US" sz="1350" b="1" dirty="0">
-                <a:solidFill>
-                  <a:srgbClr val="132A3A"/>
-                </a:solidFill>
-                <a:latin typeface="맑은 고딕" pitchFamily="34" charset="0"/>
-                <a:ea typeface="맑은 고딕" pitchFamily="34" charset="-122"/>
-                <a:cs typeface="맑은 고딕" pitchFamily="34" charset="-120"/>
-              </a:rPr>
-              <a:t>약 20,398만 원/평</a:t>
-            </a:r>
-            <a:endParaRPr lang="en-US" sz="1350" dirty="0"/>
-          </a:p>
-        </p:txBody>
-      </p:sp>
-      <p:sp>
-        <p:nvSpPr>
-          <p:cNvPr id="27" name="Shape 25"/>
           <p:cNvSpPr/>
           <p:nvPr/>
         </p:nvSpPr>
@@ -6607,7 +6721,7 @@
       </p:sp>
       <p:sp>
         <p:nvSpPr>
-          <p:cNvPr id="28" name="Shape 26"/>
+          <p:cNvPr id="25" name="Shape 23"/>
           <p:cNvSpPr/>
           <p:nvPr/>
         </p:nvSpPr>
@@ -6629,7 +6743,7 @@
       </p:sp>
       <p:sp>
         <p:nvSpPr>
-          <p:cNvPr id="29" name="Shape 27"/>
+          <p:cNvPr id="26" name="Shape 24"/>
           <p:cNvSpPr/>
           <p:nvPr/>
         </p:nvSpPr>
@@ -6649,7 +6763,7 @@
       </p:sp>
       <p:sp>
         <p:nvSpPr>
-          <p:cNvPr id="30" name="Text 28"/>
+          <p:cNvPr id="27" name="Text 25"/>
           <p:cNvSpPr/>
           <p:nvPr/>
         </p:nvSpPr>
@@ -6688,7 +6802,7 @@
       </p:sp>
       <p:sp>
         <p:nvSpPr>
-          <p:cNvPr id="31" name="Text 29"/>
+          <p:cNvPr id="28" name="Text 26"/>
           <p:cNvSpPr/>
           <p:nvPr/>
         </p:nvSpPr>
@@ -6779,7 +6893,7 @@
       </p:sp>
       <p:sp>
         <p:nvSpPr>
-          <p:cNvPr id="32" name="Text 30"/>
+          <p:cNvPr id="29" name="Text 27"/>
           <p:cNvSpPr/>
           <p:nvPr/>
         </p:nvSpPr>
@@ -6810,7 +6924,7 @@
                 <a:ea typeface="맑은 고딕" pitchFamily="34" charset="-122"/>
                 <a:cs typeface="맑은 고딕" pitchFamily="34" charset="-120"/>
               </a:rPr>
-              <a:t>CRE DEAL   |   </a:t>
+              <a:t>CRE DEAL</a:t>
             </a:r>
             <a:endParaRPr lang="en-US" sz="800" dirty="0"/>
           </a:p>
@@ -6818,7 +6932,7 @@
       </p:sp>
       <p:sp>
         <p:nvSpPr>
-          <p:cNvPr id="33" name="Text 31"/>
+          <p:cNvPr id="30" name="Text 28"/>
           <p:cNvSpPr/>
           <p:nvPr/>
         </p:nvSpPr>
@@ -7699,7 +7813,7 @@
                 <a:ea typeface="맑은 고딕" pitchFamily="34" charset="-122"/>
                 <a:cs typeface="맑은 고딕" pitchFamily="34" charset="-120"/>
               </a:rPr>
-              <a:t>CRE DEAL   |   </a:t>
+              <a:t>CRE DEAL</a:t>
             </a:r>
             <a:endParaRPr lang="en-US" sz="800" dirty="0"/>
           </a:p>
@@ -9385,7 +9499,7 @@
                 <a:ea typeface="맑은 고딕" pitchFamily="34" charset="-122"/>
                 <a:cs typeface="맑은 고딕" pitchFamily="34" charset="-120"/>
               </a:rPr>
-              <a:t>CRE DEAL   |   </a:t>
+              <a:t>CRE DEAL</a:t>
             </a:r>
             <a:endParaRPr lang="en-US" sz="800" dirty="0"/>
           </a:p>

</xml_diff>